<commit_message>
feat: roadmap deck — add 'Орындалды' progress slide (June 2026)
New slide 9: what shipped vs the plan — planned items done + extras
not in the original roadmap (KZ map, AFM checker, community voting,
threat-feeds, homoglyph) + quality (80 tests, SSRF/CORS, de-monolith).
</commit_message>
<xml_diff>
--- a/Qalqan_AI_Roadmap_2026.pptx
+++ b/Qalqan_AI_Roadmap_2026.pptx
@@ -13,6 +13,7 @@
     <p:sldId id="261" r:id="rId12"/>
     <p:sldId id="262" r:id="rId13"/>
     <p:sldId id="263" r:id="rId14"/>
+    <p:sldId id="264" r:id="rId15"/>
   </p:sldIdLst>
   <p:sldSz cx="12188952" cy="6858000" type="screen4x3"/>
   <p:notesSz cx="6858000" cy="9144000"/>
@@ -19362,6 +19363,1842 @@
                 <a:latin typeface="Segoe UI"/>
               </a:rPr>
               <a:t>🚀  Маусымда бастаймыз → Telegram Bot + Госзакупки → Тамызда финалда жеңіс</a:t>
+            </a:r>
+          </a:p>
+        </p:txBody>
+      </p:sp>
+    </p:spTree>
+  </p:cSld>
+  <p:clrMapOvr>
+    <a:masterClrMapping/>
+  </p:clrMapOvr>
+</p:sld>
+</file>
+
+<file path=ppt/slides/slide9.xml><?xml version="1.0" encoding="utf-8"?>
+<p:sld xmlns:a="http://schemas.openxmlformats.org/drawingml/2006/main" xmlns:p="http://schemas.openxmlformats.org/presentationml/2006/main" xmlns:r="http://schemas.openxmlformats.org/officeDocument/2006/relationships">
+  <p:cSld>
+    <p:spTree>
+      <p:nvGrpSpPr>
+        <p:cNvPr id="1" name=""/>
+        <p:cNvGrpSpPr/>
+        <p:nvPr/>
+      </p:nvGrpSpPr>
+      <p:grpSpPr/>
+      <p:sp>
+        <p:nvSpPr>
+          <p:cNvPr id="2" name="Rectangle 1"/>
+          <p:cNvSpPr/>
+          <p:nvPr/>
+        </p:nvSpPr>
+        <p:spPr>
+          <a:xfrm>
+            <a:off x="0" y="0"/>
+            <a:ext cx="12188952" cy="6858000"/>
+          </a:xfrm>
+          <a:prstGeom prst="rect">
+            <a:avLst/>
+          </a:prstGeom>
+          <a:solidFill>
+            <a:srgbClr val="020617"/>
+          </a:solidFill>
+          <a:ln>
+            <a:noFill/>
+          </a:ln>
+        </p:spPr>
+        <p:style>
+          <a:lnRef idx="1">
+            <a:schemeClr val="accent1"/>
+          </a:lnRef>
+          <a:fillRef idx="3">
+            <a:schemeClr val="accent1"/>
+          </a:fillRef>
+          <a:effectRef idx="2">
+            <a:schemeClr val="accent1"/>
+          </a:effectRef>
+          <a:fontRef idx="minor">
+            <a:schemeClr val="lt1"/>
+          </a:fontRef>
+        </p:style>
+        <p:txBody>
+          <a:bodyPr rtlCol="0" anchor="ctr"/>
+          <a:lstStyle/>
+          <a:p>
+            <a:pPr algn="ctr"/>
+          </a:p>
+        </p:txBody>
+      </p:sp>
+      <p:sp>
+        <p:nvSpPr>
+          <p:cNvPr id="3" name="Rectangle 2"/>
+          <p:cNvSpPr/>
+          <p:nvPr/>
+        </p:nvSpPr>
+        <p:spPr>
+          <a:xfrm>
+            <a:off x="274320" y="365760"/>
+            <a:ext cx="1184148" cy="256032"/>
+          </a:xfrm>
+          <a:prstGeom prst="rect">
+            <a:avLst/>
+          </a:prstGeom>
+          <a:solidFill>
+            <a:srgbClr val="042E20"/>
+          </a:solidFill>
+          <a:ln w="6350">
+            <a:solidFill>
+              <a:srgbClr val="10B981"/>
+            </a:solidFill>
+          </a:ln>
+        </p:spPr>
+        <p:style>
+          <a:lnRef idx="1">
+            <a:schemeClr val="accent1"/>
+          </a:lnRef>
+          <a:fillRef idx="3">
+            <a:schemeClr val="accent1"/>
+          </a:fillRef>
+          <a:effectRef idx="2">
+            <a:schemeClr val="accent1"/>
+          </a:effectRef>
+          <a:fontRef idx="minor">
+            <a:schemeClr val="lt1"/>
+          </a:fontRef>
+        </p:style>
+        <p:txBody>
+          <a:bodyPr rtlCol="0" anchor="ctr"/>
+          <a:lstStyle/>
+          <a:p>
+            <a:pPr algn="ctr"/>
+          </a:p>
+        </p:txBody>
+      </p:sp>
+      <p:sp>
+        <p:nvSpPr>
+          <p:cNvPr id="4" name="TextBox 3"/>
+          <p:cNvSpPr txBox="1"/>
+          <p:nvPr/>
+        </p:nvSpPr>
+        <p:spPr>
+          <a:xfrm>
+            <a:off x="347472" y="384048"/>
+            <a:ext cx="1184148" cy="256032"/>
+          </a:xfrm>
+          <a:prstGeom prst="rect">
+            <a:avLst/>
+          </a:prstGeom>
+          <a:noFill/>
+        </p:spPr>
+        <p:txBody>
+          <a:bodyPr wrap="square">
+            <a:spAutoFit/>
+          </a:bodyPr>
+          <a:lstStyle/>
+          <a:p>
+            <a:pPr algn="l"/>
+            <a:r>
+              <a:rPr sz="900" b="1" i="0">
+                <a:solidFill>
+                  <a:srgbClr val="10B981"/>
+                </a:solidFill>
+                <a:latin typeface="Segoe UI"/>
+              </a:rPr>
+              <a:t>2026 МАУСЫМ</a:t>
+            </a:r>
+          </a:p>
+        </p:txBody>
+      </p:sp>
+      <p:sp>
+        <p:nvSpPr>
+          <p:cNvPr id="5" name="TextBox 4"/>
+          <p:cNvSpPr txBox="1"/>
+          <p:nvPr/>
+        </p:nvSpPr>
+        <p:spPr>
+          <a:xfrm>
+            <a:off x="274320" y="713232"/>
+            <a:ext cx="11612880" cy="640080"/>
+          </a:xfrm>
+          <a:prstGeom prst="rect">
+            <a:avLst/>
+          </a:prstGeom>
+          <a:noFill/>
+        </p:spPr>
+        <p:txBody>
+          <a:bodyPr wrap="square">
+            <a:spAutoFit/>
+          </a:bodyPr>
+          <a:lstStyle/>
+          <a:p>
+            <a:pPr algn="l"/>
+            <a:r>
+              <a:rPr sz="2800" b="1" i="0">
+                <a:solidFill>
+                  <a:srgbClr val="F8FAFC"/>
+                </a:solidFill>
+                <a:latin typeface="Segoe UI"/>
+              </a:rPr>
+              <a:t>ОРЫНДАЛДЫ — жоспардан асып</a:t>
+            </a:r>
+          </a:p>
+        </p:txBody>
+      </p:sp>
+      <p:sp>
+        <p:nvSpPr>
+          <p:cNvPr id="6" name="Rectangle 5"/>
+          <p:cNvSpPr/>
+          <p:nvPr/>
+        </p:nvSpPr>
+        <p:spPr>
+          <a:xfrm>
+            <a:off x="292608" y="1417320"/>
+            <a:ext cx="1828800" cy="36576"/>
+          </a:xfrm>
+          <a:prstGeom prst="rect">
+            <a:avLst/>
+          </a:prstGeom>
+          <a:solidFill>
+            <a:srgbClr val="10B981"/>
+          </a:solidFill>
+          <a:ln>
+            <a:noFill/>
+          </a:ln>
+        </p:spPr>
+        <p:style>
+          <a:lnRef idx="1">
+            <a:schemeClr val="accent1"/>
+          </a:lnRef>
+          <a:fillRef idx="3">
+            <a:schemeClr val="accent1"/>
+          </a:fillRef>
+          <a:effectRef idx="2">
+            <a:schemeClr val="accent1"/>
+          </a:effectRef>
+          <a:fontRef idx="minor">
+            <a:schemeClr val="lt1"/>
+          </a:fontRef>
+        </p:style>
+        <p:txBody>
+          <a:bodyPr rtlCol="0" anchor="ctr"/>
+          <a:lstStyle/>
+          <a:p>
+            <a:pPr algn="ctr"/>
+          </a:p>
+        </p:txBody>
+      </p:sp>
+      <p:sp>
+        <p:nvSpPr>
+          <p:cNvPr id="7" name="Rectangle 6"/>
+          <p:cNvSpPr/>
+          <p:nvPr/>
+        </p:nvSpPr>
+        <p:spPr>
+          <a:xfrm>
+            <a:off x="274320" y="1691640"/>
+            <a:ext cx="3794760" cy="4206240"/>
+          </a:xfrm>
+          <a:prstGeom prst="rect">
+            <a:avLst/>
+          </a:prstGeom>
+          <a:solidFill>
+            <a:srgbClr val="0D1426"/>
+          </a:solidFill>
+          <a:ln w="9525">
+            <a:solidFill>
+              <a:srgbClr val="334155"/>
+            </a:solidFill>
+          </a:ln>
+        </p:spPr>
+        <p:style>
+          <a:lnRef idx="1">
+            <a:schemeClr val="accent1"/>
+          </a:lnRef>
+          <a:fillRef idx="3">
+            <a:schemeClr val="accent1"/>
+          </a:fillRef>
+          <a:effectRef idx="2">
+            <a:schemeClr val="accent1"/>
+          </a:effectRef>
+          <a:fontRef idx="minor">
+            <a:schemeClr val="lt1"/>
+          </a:fontRef>
+        </p:style>
+        <p:txBody>
+          <a:bodyPr rtlCol="0" anchor="ctr"/>
+          <a:lstStyle/>
+          <a:p>
+            <a:pPr algn="ctr"/>
+          </a:p>
+        </p:txBody>
+      </p:sp>
+      <p:sp>
+        <p:nvSpPr>
+          <p:cNvPr id="8" name="Rectangle 7"/>
+          <p:cNvSpPr/>
+          <p:nvPr/>
+        </p:nvSpPr>
+        <p:spPr>
+          <a:xfrm>
+            <a:off x="274320" y="1691640"/>
+            <a:ext cx="3794760" cy="36576"/>
+          </a:xfrm>
+          <a:prstGeom prst="rect">
+            <a:avLst/>
+          </a:prstGeom>
+          <a:solidFill>
+            <a:srgbClr val="10B981"/>
+          </a:solidFill>
+          <a:ln>
+            <a:noFill/>
+          </a:ln>
+        </p:spPr>
+        <p:style>
+          <a:lnRef idx="1">
+            <a:schemeClr val="accent1"/>
+          </a:lnRef>
+          <a:fillRef idx="3">
+            <a:schemeClr val="accent1"/>
+          </a:fillRef>
+          <a:effectRef idx="2">
+            <a:schemeClr val="accent1"/>
+          </a:effectRef>
+          <a:fontRef idx="minor">
+            <a:schemeClr val="lt1"/>
+          </a:fontRef>
+        </p:style>
+        <p:txBody>
+          <a:bodyPr rtlCol="0" anchor="ctr"/>
+          <a:lstStyle/>
+          <a:p>
+            <a:pPr algn="ctr"/>
+          </a:p>
+        </p:txBody>
+      </p:sp>
+      <p:sp>
+        <p:nvSpPr>
+          <p:cNvPr id="9" name="TextBox 8"/>
+          <p:cNvSpPr txBox="1"/>
+          <p:nvPr/>
+        </p:nvSpPr>
+        <p:spPr>
+          <a:xfrm>
+            <a:off x="457200" y="1828800"/>
+            <a:ext cx="3429000" cy="365760"/>
+          </a:xfrm>
+          <a:prstGeom prst="rect">
+            <a:avLst/>
+          </a:prstGeom>
+          <a:noFill/>
+        </p:spPr>
+        <p:txBody>
+          <a:bodyPr wrap="square">
+            <a:spAutoFit/>
+          </a:bodyPr>
+          <a:lstStyle/>
+          <a:p>
+            <a:pPr algn="l"/>
+            <a:r>
+              <a:rPr sz="1500" b="1" i="0">
+                <a:solidFill>
+                  <a:srgbClr val="F8FAFC"/>
+                </a:solidFill>
+                <a:latin typeface="Segoe UI"/>
+              </a:rPr>
+              <a:t>✅  ЖОСПАР БОЙЫНША</a:t>
+            </a:r>
+          </a:p>
+        </p:txBody>
+      </p:sp>
+      <p:sp>
+        <p:nvSpPr>
+          <p:cNvPr id="10" name="Oval 9"/>
+          <p:cNvSpPr/>
+          <p:nvPr/>
+        </p:nvSpPr>
+        <p:spPr>
+          <a:xfrm>
+            <a:off x="457200" y="2395728"/>
+            <a:ext cx="91440" cy="91440"/>
+          </a:xfrm>
+          <a:prstGeom prst="ellipse">
+            <a:avLst/>
+          </a:prstGeom>
+          <a:solidFill>
+            <a:srgbClr val="10B981"/>
+          </a:solidFill>
+          <a:ln>
+            <a:noFill/>
+          </a:ln>
+        </p:spPr>
+        <p:style>
+          <a:lnRef idx="1">
+            <a:schemeClr val="accent1"/>
+          </a:lnRef>
+          <a:fillRef idx="3">
+            <a:schemeClr val="accent1"/>
+          </a:fillRef>
+          <a:effectRef idx="2">
+            <a:schemeClr val="accent1"/>
+          </a:effectRef>
+          <a:fontRef idx="minor">
+            <a:schemeClr val="lt1"/>
+          </a:fontRef>
+        </p:style>
+        <p:txBody>
+          <a:bodyPr rtlCol="0" anchor="ctr"/>
+          <a:lstStyle/>
+          <a:p>
+            <a:pPr algn="ctr"/>
+          </a:p>
+        </p:txBody>
+      </p:sp>
+      <p:sp>
+        <p:nvSpPr>
+          <p:cNvPr id="11" name="TextBox 10"/>
+          <p:cNvSpPr txBox="1"/>
+          <p:nvPr/>
+        </p:nvSpPr>
+        <p:spPr>
+          <a:xfrm>
+            <a:off x="621792" y="2286000"/>
+            <a:ext cx="3291840" cy="347472"/>
+          </a:xfrm>
+          <a:prstGeom prst="rect">
+            <a:avLst/>
+          </a:prstGeom>
+          <a:noFill/>
+        </p:spPr>
+        <p:txBody>
+          <a:bodyPr wrap="square">
+            <a:spAutoFit/>
+          </a:bodyPr>
+          <a:lstStyle/>
+          <a:p>
+            <a:pPr algn="l"/>
+            <a:r>
+              <a:rPr sz="1250" b="0" i="0">
+                <a:solidFill>
+                  <a:srgbClr val="F8FAFC"/>
+                </a:solidFill>
+                <a:latin typeface="Segoe UI"/>
+              </a:rPr>
+              <a:t>Госзакуп fraud detection</a:t>
+            </a:r>
+          </a:p>
+        </p:txBody>
+      </p:sp>
+      <p:sp>
+        <p:nvSpPr>
+          <p:cNvPr id="12" name="Oval 11"/>
+          <p:cNvSpPr/>
+          <p:nvPr/>
+        </p:nvSpPr>
+        <p:spPr>
+          <a:xfrm>
+            <a:off x="457200" y="2962656"/>
+            <a:ext cx="91440" cy="91440"/>
+          </a:xfrm>
+          <a:prstGeom prst="ellipse">
+            <a:avLst/>
+          </a:prstGeom>
+          <a:solidFill>
+            <a:srgbClr val="10B981"/>
+          </a:solidFill>
+          <a:ln>
+            <a:noFill/>
+          </a:ln>
+        </p:spPr>
+        <p:style>
+          <a:lnRef idx="1">
+            <a:schemeClr val="accent1"/>
+          </a:lnRef>
+          <a:fillRef idx="3">
+            <a:schemeClr val="accent1"/>
+          </a:fillRef>
+          <a:effectRef idx="2">
+            <a:schemeClr val="accent1"/>
+          </a:effectRef>
+          <a:fontRef idx="minor">
+            <a:schemeClr val="lt1"/>
+          </a:fontRef>
+        </p:style>
+        <p:txBody>
+          <a:bodyPr rtlCol="0" anchor="ctr"/>
+          <a:lstStyle/>
+          <a:p>
+            <a:pPr algn="ctr"/>
+          </a:p>
+        </p:txBody>
+      </p:sp>
+      <p:sp>
+        <p:nvSpPr>
+          <p:cNvPr id="13" name="TextBox 12"/>
+          <p:cNvSpPr txBox="1"/>
+          <p:nvPr/>
+        </p:nvSpPr>
+        <p:spPr>
+          <a:xfrm>
+            <a:off x="621792" y="2852928"/>
+            <a:ext cx="3291840" cy="347472"/>
+          </a:xfrm>
+          <a:prstGeom prst="rect">
+            <a:avLst/>
+          </a:prstGeom>
+          <a:noFill/>
+        </p:spPr>
+        <p:txBody>
+          <a:bodyPr wrap="square">
+            <a:spAutoFit/>
+          </a:bodyPr>
+          <a:lstStyle/>
+          <a:p>
+            <a:pPr algn="l"/>
+            <a:r>
+              <a:rPr sz="1250" b="0" i="0">
+                <a:solidFill>
+                  <a:srgbClr val="F8FAFC"/>
+                </a:solidFill>
+                <a:latin typeface="Segoe UI"/>
+              </a:rPr>
+              <a:t>Telegram бот (7 пәрмен)</a:t>
+            </a:r>
+          </a:p>
+        </p:txBody>
+      </p:sp>
+      <p:sp>
+        <p:nvSpPr>
+          <p:cNvPr id="14" name="Oval 13"/>
+          <p:cNvSpPr/>
+          <p:nvPr/>
+        </p:nvSpPr>
+        <p:spPr>
+          <a:xfrm>
+            <a:off x="457200" y="3529584"/>
+            <a:ext cx="91440" cy="91440"/>
+          </a:xfrm>
+          <a:prstGeom prst="ellipse">
+            <a:avLst/>
+          </a:prstGeom>
+          <a:solidFill>
+            <a:srgbClr val="10B981"/>
+          </a:solidFill>
+          <a:ln>
+            <a:noFill/>
+          </a:ln>
+        </p:spPr>
+        <p:style>
+          <a:lnRef idx="1">
+            <a:schemeClr val="accent1"/>
+          </a:lnRef>
+          <a:fillRef idx="3">
+            <a:schemeClr val="accent1"/>
+          </a:fillRef>
+          <a:effectRef idx="2">
+            <a:schemeClr val="accent1"/>
+          </a:effectRef>
+          <a:fontRef idx="minor">
+            <a:schemeClr val="lt1"/>
+          </a:fontRef>
+        </p:style>
+        <p:txBody>
+          <a:bodyPr rtlCol="0" anchor="ctr"/>
+          <a:lstStyle/>
+          <a:p>
+            <a:pPr algn="ctr"/>
+          </a:p>
+        </p:txBody>
+      </p:sp>
+      <p:sp>
+        <p:nvSpPr>
+          <p:cNvPr id="15" name="TextBox 14"/>
+          <p:cNvSpPr txBox="1"/>
+          <p:nvPr/>
+        </p:nvSpPr>
+        <p:spPr>
+          <a:xfrm>
+            <a:off x="621792" y="3419856"/>
+            <a:ext cx="3291840" cy="347472"/>
+          </a:xfrm>
+          <a:prstGeom prst="rect">
+            <a:avLst/>
+          </a:prstGeom>
+          <a:noFill/>
+        </p:spPr>
+        <p:txBody>
+          <a:bodyPr wrap="square">
+            <a:spAutoFit/>
+          </a:bodyPr>
+          <a:lstStyle/>
+          <a:p>
+            <a:pPr algn="l"/>
+            <a:r>
+              <a:rPr sz="1250" b="0" i="0">
+                <a:solidFill>
+                  <a:srgbClr val="F8FAFC"/>
+                </a:solidFill>
+                <a:latin typeface="Segoe UI"/>
+              </a:rPr>
+              <a:t>Firefox кеңейтім</a:t>
+            </a:r>
+          </a:p>
+        </p:txBody>
+      </p:sp>
+      <p:sp>
+        <p:nvSpPr>
+          <p:cNvPr id="16" name="Oval 15"/>
+          <p:cNvSpPr/>
+          <p:nvPr/>
+        </p:nvSpPr>
+        <p:spPr>
+          <a:xfrm>
+            <a:off x="457200" y="4096512"/>
+            <a:ext cx="91440" cy="91440"/>
+          </a:xfrm>
+          <a:prstGeom prst="ellipse">
+            <a:avLst/>
+          </a:prstGeom>
+          <a:solidFill>
+            <a:srgbClr val="10B981"/>
+          </a:solidFill>
+          <a:ln>
+            <a:noFill/>
+          </a:ln>
+        </p:spPr>
+        <p:style>
+          <a:lnRef idx="1">
+            <a:schemeClr val="accent1"/>
+          </a:lnRef>
+          <a:fillRef idx="3">
+            <a:schemeClr val="accent1"/>
+          </a:fillRef>
+          <a:effectRef idx="2">
+            <a:schemeClr val="accent1"/>
+          </a:effectRef>
+          <a:fontRef idx="minor">
+            <a:schemeClr val="lt1"/>
+          </a:fontRef>
+        </p:style>
+        <p:txBody>
+          <a:bodyPr rtlCol="0" anchor="ctr"/>
+          <a:lstStyle/>
+          <a:p>
+            <a:pPr algn="ctr"/>
+          </a:p>
+        </p:txBody>
+      </p:sp>
+      <p:sp>
+        <p:nvSpPr>
+          <p:cNvPr id="17" name="TextBox 16"/>
+          <p:cNvSpPr txBox="1"/>
+          <p:nvPr/>
+        </p:nvSpPr>
+        <p:spPr>
+          <a:xfrm>
+            <a:off x="621792" y="3986784"/>
+            <a:ext cx="3291840" cy="347472"/>
+          </a:xfrm>
+          <a:prstGeom prst="rect">
+            <a:avLst/>
+          </a:prstGeom>
+          <a:noFill/>
+        </p:spPr>
+        <p:txBody>
+          <a:bodyPr wrap="square">
+            <a:spAutoFit/>
+          </a:bodyPr>
+          <a:lstStyle/>
+          <a:p>
+            <a:pPr algn="l"/>
+            <a:r>
+              <a:rPr sz="1250" b="0" i="0">
+                <a:solidFill>
+                  <a:srgbClr val="F8FAFC"/>
+                </a:solidFill>
+                <a:latin typeface="Segoe UI"/>
+              </a:rPr>
+              <a:t>PWA + лендинг + статистика</a:t>
+            </a:r>
+          </a:p>
+        </p:txBody>
+      </p:sp>
+      <p:sp>
+        <p:nvSpPr>
+          <p:cNvPr id="18" name="Oval 17"/>
+          <p:cNvSpPr/>
+          <p:nvPr/>
+        </p:nvSpPr>
+        <p:spPr>
+          <a:xfrm>
+            <a:off x="457200" y="4663440"/>
+            <a:ext cx="91440" cy="91440"/>
+          </a:xfrm>
+          <a:prstGeom prst="ellipse">
+            <a:avLst/>
+          </a:prstGeom>
+          <a:solidFill>
+            <a:srgbClr val="10B981"/>
+          </a:solidFill>
+          <a:ln>
+            <a:noFill/>
+          </a:ln>
+        </p:spPr>
+        <p:style>
+          <a:lnRef idx="1">
+            <a:schemeClr val="accent1"/>
+          </a:lnRef>
+          <a:fillRef idx="3">
+            <a:schemeClr val="accent1"/>
+          </a:fillRef>
+          <a:effectRef idx="2">
+            <a:schemeClr val="accent1"/>
+          </a:effectRef>
+          <a:fontRef idx="minor">
+            <a:schemeClr val="lt1"/>
+          </a:fontRef>
+        </p:style>
+        <p:txBody>
+          <a:bodyPr rtlCol="0" anchor="ctr"/>
+          <a:lstStyle/>
+          <a:p>
+            <a:pPr algn="ctr"/>
+          </a:p>
+        </p:txBody>
+      </p:sp>
+      <p:sp>
+        <p:nvSpPr>
+          <p:cNvPr id="19" name="TextBox 18"/>
+          <p:cNvSpPr txBox="1"/>
+          <p:nvPr/>
+        </p:nvSpPr>
+        <p:spPr>
+          <a:xfrm>
+            <a:off x="621792" y="4553712"/>
+            <a:ext cx="3291840" cy="347472"/>
+          </a:xfrm>
+          <a:prstGeom prst="rect">
+            <a:avLst/>
+          </a:prstGeom>
+          <a:noFill/>
+        </p:spPr>
+        <p:txBody>
+          <a:bodyPr wrap="square">
+            <a:spAutoFit/>
+          </a:bodyPr>
+          <a:lstStyle/>
+          <a:p>
+            <a:pPr algn="l"/>
+            <a:r>
+              <a:rPr sz="1250" b="0" i="0">
+                <a:solidFill>
+                  <a:srgbClr val="F8FAFC"/>
+                </a:solidFill>
+                <a:latin typeface="Segoe UI"/>
+              </a:rPr>
+              <a:t>Офлайн-DB 390+ домен</a:t>
+            </a:r>
+          </a:p>
+        </p:txBody>
+      </p:sp>
+      <p:sp>
+        <p:nvSpPr>
+          <p:cNvPr id="20" name="Rectangle 19"/>
+          <p:cNvSpPr/>
+          <p:nvPr/>
+        </p:nvSpPr>
+        <p:spPr>
+          <a:xfrm>
+            <a:off x="4206240" y="1691640"/>
+            <a:ext cx="3794760" cy="4206240"/>
+          </a:xfrm>
+          <a:prstGeom prst="rect">
+            <a:avLst/>
+          </a:prstGeom>
+          <a:solidFill>
+            <a:srgbClr val="0D1426"/>
+          </a:solidFill>
+          <a:ln w="9525">
+            <a:solidFill>
+              <a:srgbClr val="334155"/>
+            </a:solidFill>
+          </a:ln>
+        </p:spPr>
+        <p:style>
+          <a:lnRef idx="1">
+            <a:schemeClr val="accent1"/>
+          </a:lnRef>
+          <a:fillRef idx="3">
+            <a:schemeClr val="accent1"/>
+          </a:fillRef>
+          <a:effectRef idx="2">
+            <a:schemeClr val="accent1"/>
+          </a:effectRef>
+          <a:fontRef idx="minor">
+            <a:schemeClr val="lt1"/>
+          </a:fontRef>
+        </p:style>
+        <p:txBody>
+          <a:bodyPr rtlCol="0" anchor="ctr"/>
+          <a:lstStyle/>
+          <a:p>
+            <a:pPr algn="ctr"/>
+          </a:p>
+        </p:txBody>
+      </p:sp>
+      <p:sp>
+        <p:nvSpPr>
+          <p:cNvPr id="21" name="Rectangle 20"/>
+          <p:cNvSpPr/>
+          <p:nvPr/>
+        </p:nvSpPr>
+        <p:spPr>
+          <a:xfrm>
+            <a:off x="4206240" y="1691640"/>
+            <a:ext cx="3794760" cy="36576"/>
+          </a:xfrm>
+          <a:prstGeom prst="rect">
+            <a:avLst/>
+          </a:prstGeom>
+          <a:solidFill>
+            <a:srgbClr val="8B5CF6"/>
+          </a:solidFill>
+          <a:ln>
+            <a:noFill/>
+          </a:ln>
+        </p:spPr>
+        <p:style>
+          <a:lnRef idx="1">
+            <a:schemeClr val="accent1"/>
+          </a:lnRef>
+          <a:fillRef idx="3">
+            <a:schemeClr val="accent1"/>
+          </a:fillRef>
+          <a:effectRef idx="2">
+            <a:schemeClr val="accent1"/>
+          </a:effectRef>
+          <a:fontRef idx="minor">
+            <a:schemeClr val="lt1"/>
+          </a:fontRef>
+        </p:style>
+        <p:txBody>
+          <a:bodyPr rtlCol="0" anchor="ctr"/>
+          <a:lstStyle/>
+          <a:p>
+            <a:pPr algn="ctr"/>
+          </a:p>
+        </p:txBody>
+      </p:sp>
+      <p:sp>
+        <p:nvSpPr>
+          <p:cNvPr id="22" name="TextBox 21"/>
+          <p:cNvSpPr txBox="1"/>
+          <p:nvPr/>
+        </p:nvSpPr>
+        <p:spPr>
+          <a:xfrm>
+            <a:off x="4389120" y="1828800"/>
+            <a:ext cx="3429000" cy="365760"/>
+          </a:xfrm>
+          <a:prstGeom prst="rect">
+            <a:avLst/>
+          </a:prstGeom>
+          <a:noFill/>
+        </p:spPr>
+        <p:txBody>
+          <a:bodyPr wrap="square">
+            <a:spAutoFit/>
+          </a:bodyPr>
+          <a:lstStyle/>
+          <a:p>
+            <a:pPr algn="l"/>
+            <a:r>
+              <a:rPr sz="1500" b="1" i="0">
+                <a:solidFill>
+                  <a:srgbClr val="F8FAFC"/>
+                </a:solidFill>
+                <a:latin typeface="Segoe UI"/>
+              </a:rPr>
+              <a:t>ҚОСЫМША — жоспарда жоқ</a:t>
+            </a:r>
+          </a:p>
+        </p:txBody>
+      </p:sp>
+      <p:sp>
+        <p:nvSpPr>
+          <p:cNvPr id="23" name="Oval 22"/>
+          <p:cNvSpPr/>
+          <p:nvPr/>
+        </p:nvSpPr>
+        <p:spPr>
+          <a:xfrm>
+            <a:off x="4389120" y="2395728"/>
+            <a:ext cx="91440" cy="91440"/>
+          </a:xfrm>
+          <a:prstGeom prst="ellipse">
+            <a:avLst/>
+          </a:prstGeom>
+          <a:solidFill>
+            <a:srgbClr val="8B5CF6"/>
+          </a:solidFill>
+          <a:ln>
+            <a:noFill/>
+          </a:ln>
+        </p:spPr>
+        <p:style>
+          <a:lnRef idx="1">
+            <a:schemeClr val="accent1"/>
+          </a:lnRef>
+          <a:fillRef idx="3">
+            <a:schemeClr val="accent1"/>
+          </a:fillRef>
+          <a:effectRef idx="2">
+            <a:schemeClr val="accent1"/>
+          </a:effectRef>
+          <a:fontRef idx="minor">
+            <a:schemeClr val="lt1"/>
+          </a:fontRef>
+        </p:style>
+        <p:txBody>
+          <a:bodyPr rtlCol="0" anchor="ctr"/>
+          <a:lstStyle/>
+          <a:p>
+            <a:pPr algn="ctr"/>
+          </a:p>
+        </p:txBody>
+      </p:sp>
+      <p:sp>
+        <p:nvSpPr>
+          <p:cNvPr id="24" name="TextBox 23"/>
+          <p:cNvSpPr txBox="1"/>
+          <p:nvPr/>
+        </p:nvSpPr>
+        <p:spPr>
+          <a:xfrm>
+            <a:off x="4553712" y="2286000"/>
+            <a:ext cx="3291840" cy="347472"/>
+          </a:xfrm>
+          <a:prstGeom prst="rect">
+            <a:avLst/>
+          </a:prstGeom>
+          <a:noFill/>
+        </p:spPr>
+        <p:txBody>
+          <a:bodyPr wrap="square">
+            <a:spAutoFit/>
+          </a:bodyPr>
+          <a:lstStyle/>
+          <a:p>
+            <a:pPr algn="l"/>
+            <a:r>
+              <a:rPr sz="1250" b="0" i="0">
+                <a:solidFill>
+                  <a:srgbClr val="F8FAFC"/>
+                </a:solidFill>
+                <a:latin typeface="Segoe UI"/>
+              </a:rPr>
+              <a:t>KZ облыстық қауіп картасы</a:t>
+            </a:r>
+          </a:p>
+        </p:txBody>
+      </p:sp>
+      <p:sp>
+        <p:nvSpPr>
+          <p:cNvPr id="25" name="Oval 24"/>
+          <p:cNvSpPr/>
+          <p:nvPr/>
+        </p:nvSpPr>
+        <p:spPr>
+          <a:xfrm>
+            <a:off x="4389120" y="2962656"/>
+            <a:ext cx="91440" cy="91440"/>
+          </a:xfrm>
+          <a:prstGeom prst="ellipse">
+            <a:avLst/>
+          </a:prstGeom>
+          <a:solidFill>
+            <a:srgbClr val="8B5CF6"/>
+          </a:solidFill>
+          <a:ln>
+            <a:noFill/>
+          </a:ln>
+        </p:spPr>
+        <p:style>
+          <a:lnRef idx="1">
+            <a:schemeClr val="accent1"/>
+          </a:lnRef>
+          <a:fillRef idx="3">
+            <a:schemeClr val="accent1"/>
+          </a:fillRef>
+          <a:effectRef idx="2">
+            <a:schemeClr val="accent1"/>
+          </a:effectRef>
+          <a:fontRef idx="minor">
+            <a:schemeClr val="lt1"/>
+          </a:fontRef>
+        </p:style>
+        <p:txBody>
+          <a:bodyPr rtlCol="0" anchor="ctr"/>
+          <a:lstStyle/>
+          <a:p>
+            <a:pPr algn="ctr"/>
+          </a:p>
+        </p:txBody>
+      </p:sp>
+      <p:sp>
+        <p:nvSpPr>
+          <p:cNvPr id="26" name="TextBox 25"/>
+          <p:cNvSpPr txBox="1"/>
+          <p:nvPr/>
+        </p:nvSpPr>
+        <p:spPr>
+          <a:xfrm>
+            <a:off x="4553712" y="2852928"/>
+            <a:ext cx="3291840" cy="347472"/>
+          </a:xfrm>
+          <a:prstGeom prst="rect">
+            <a:avLst/>
+          </a:prstGeom>
+          <a:noFill/>
+        </p:spPr>
+        <p:txBody>
+          <a:bodyPr wrap="square">
+            <a:spAutoFit/>
+          </a:bodyPr>
+          <a:lstStyle/>
+          <a:p>
+            <a:pPr algn="l"/>
+            <a:r>
+              <a:rPr sz="1250" b="0" i="0">
+                <a:solidFill>
+                  <a:srgbClr val="F8FAFC"/>
+                </a:solidFill>
+                <a:latin typeface="Segoe UI"/>
+              </a:rPr>
+              <a:t>АФМ-пирамида чек (атау)</a:t>
+            </a:r>
+          </a:p>
+        </p:txBody>
+      </p:sp>
+      <p:sp>
+        <p:nvSpPr>
+          <p:cNvPr id="27" name="Oval 26"/>
+          <p:cNvSpPr/>
+          <p:nvPr/>
+        </p:nvSpPr>
+        <p:spPr>
+          <a:xfrm>
+            <a:off x="4389120" y="3529584"/>
+            <a:ext cx="91440" cy="91440"/>
+          </a:xfrm>
+          <a:prstGeom prst="ellipse">
+            <a:avLst/>
+          </a:prstGeom>
+          <a:solidFill>
+            <a:srgbClr val="8B5CF6"/>
+          </a:solidFill>
+          <a:ln>
+            <a:noFill/>
+          </a:ln>
+        </p:spPr>
+        <p:style>
+          <a:lnRef idx="1">
+            <a:schemeClr val="accent1"/>
+          </a:lnRef>
+          <a:fillRef idx="3">
+            <a:schemeClr val="accent1"/>
+          </a:fillRef>
+          <a:effectRef idx="2">
+            <a:schemeClr val="accent1"/>
+          </a:effectRef>
+          <a:fontRef idx="minor">
+            <a:schemeClr val="lt1"/>
+          </a:fontRef>
+        </p:style>
+        <p:txBody>
+          <a:bodyPr rtlCol="0" anchor="ctr"/>
+          <a:lstStyle/>
+          <a:p>
+            <a:pPr algn="ctr"/>
+          </a:p>
+        </p:txBody>
+      </p:sp>
+      <p:sp>
+        <p:nvSpPr>
+          <p:cNvPr id="28" name="TextBox 27"/>
+          <p:cNvSpPr txBox="1"/>
+          <p:nvPr/>
+        </p:nvSpPr>
+        <p:spPr>
+          <a:xfrm>
+            <a:off x="4553712" y="3419856"/>
+            <a:ext cx="3291840" cy="347472"/>
+          </a:xfrm>
+          <a:prstGeom prst="rect">
+            <a:avLst/>
+          </a:prstGeom>
+          <a:noFill/>
+        </p:spPr>
+        <p:txBody>
+          <a:bodyPr wrap="square">
+            <a:spAutoFit/>
+          </a:bodyPr>
+          <a:lstStyle/>
+          <a:p>
+            <a:pPr algn="l"/>
+            <a:r>
+              <a:rPr sz="1250" b="0" i="0">
+                <a:solidFill>
+                  <a:srgbClr val="F8FAFC"/>
+                </a:solidFill>
+                <a:latin typeface="Segoe UI"/>
+              </a:rPr>
+              <a:t>Community voting + батырмалар</a:t>
+            </a:r>
+          </a:p>
+        </p:txBody>
+      </p:sp>
+      <p:sp>
+        <p:nvSpPr>
+          <p:cNvPr id="29" name="Oval 28"/>
+          <p:cNvSpPr/>
+          <p:nvPr/>
+        </p:nvSpPr>
+        <p:spPr>
+          <a:xfrm>
+            <a:off x="4389120" y="4096512"/>
+            <a:ext cx="91440" cy="91440"/>
+          </a:xfrm>
+          <a:prstGeom prst="ellipse">
+            <a:avLst/>
+          </a:prstGeom>
+          <a:solidFill>
+            <a:srgbClr val="8B5CF6"/>
+          </a:solidFill>
+          <a:ln>
+            <a:noFill/>
+          </a:ln>
+        </p:spPr>
+        <p:style>
+          <a:lnRef idx="1">
+            <a:schemeClr val="accent1"/>
+          </a:lnRef>
+          <a:fillRef idx="3">
+            <a:schemeClr val="accent1"/>
+          </a:fillRef>
+          <a:effectRef idx="2">
+            <a:schemeClr val="accent1"/>
+          </a:effectRef>
+          <a:fontRef idx="minor">
+            <a:schemeClr val="lt1"/>
+          </a:fontRef>
+        </p:style>
+        <p:txBody>
+          <a:bodyPr rtlCol="0" anchor="ctr"/>
+          <a:lstStyle/>
+          <a:p>
+            <a:pPr algn="ctr"/>
+          </a:p>
+        </p:txBody>
+      </p:sp>
+      <p:sp>
+        <p:nvSpPr>
+          <p:cNvPr id="30" name="TextBox 29"/>
+          <p:cNvSpPr txBox="1"/>
+          <p:nvPr/>
+        </p:nvSpPr>
+        <p:spPr>
+          <a:xfrm>
+            <a:off x="4553712" y="3986784"/>
+            <a:ext cx="3291840" cy="347472"/>
+          </a:xfrm>
+          <a:prstGeom prst="rect">
+            <a:avLst/>
+          </a:prstGeom>
+          <a:noFill/>
+        </p:spPr>
+        <p:txBody>
+          <a:bodyPr wrap="square">
+            <a:spAutoFit/>
+          </a:bodyPr>
+          <a:lstStyle/>
+          <a:p>
+            <a:pPr algn="l"/>
+            <a:r>
+              <a:rPr sz="1250" b="0" i="0">
+                <a:solidFill>
+                  <a:srgbClr val="F8FAFC"/>
+                </a:solidFill>
+                <a:latin typeface="Segoe UI"/>
+              </a:rPr>
+              <a:t>Threat-feeds + ашық KZ-фид</a:t>
+            </a:r>
+          </a:p>
+        </p:txBody>
+      </p:sp>
+      <p:sp>
+        <p:nvSpPr>
+          <p:cNvPr id="31" name="Oval 30"/>
+          <p:cNvSpPr/>
+          <p:nvPr/>
+        </p:nvSpPr>
+        <p:spPr>
+          <a:xfrm>
+            <a:off x="4389120" y="4663440"/>
+            <a:ext cx="91440" cy="91440"/>
+          </a:xfrm>
+          <a:prstGeom prst="ellipse">
+            <a:avLst/>
+          </a:prstGeom>
+          <a:solidFill>
+            <a:srgbClr val="8B5CF6"/>
+          </a:solidFill>
+          <a:ln>
+            <a:noFill/>
+          </a:ln>
+        </p:spPr>
+        <p:style>
+          <a:lnRef idx="1">
+            <a:schemeClr val="accent1"/>
+          </a:lnRef>
+          <a:fillRef idx="3">
+            <a:schemeClr val="accent1"/>
+          </a:fillRef>
+          <a:effectRef idx="2">
+            <a:schemeClr val="accent1"/>
+          </a:effectRef>
+          <a:fontRef idx="minor">
+            <a:schemeClr val="lt1"/>
+          </a:fontRef>
+        </p:style>
+        <p:txBody>
+          <a:bodyPr rtlCol="0" anchor="ctr"/>
+          <a:lstStyle/>
+          <a:p>
+            <a:pPr algn="ctr"/>
+          </a:p>
+        </p:txBody>
+      </p:sp>
+      <p:sp>
+        <p:nvSpPr>
+          <p:cNvPr id="32" name="TextBox 31"/>
+          <p:cNvSpPr txBox="1"/>
+          <p:nvPr/>
+        </p:nvSpPr>
+        <p:spPr>
+          <a:xfrm>
+            <a:off x="4553712" y="4553712"/>
+            <a:ext cx="3291840" cy="347472"/>
+          </a:xfrm>
+          <a:prstGeom prst="rect">
+            <a:avLst/>
+          </a:prstGeom>
+          <a:noFill/>
+        </p:spPr>
+        <p:txBody>
+          <a:bodyPr wrap="square">
+            <a:spAutoFit/>
+          </a:bodyPr>
+          <a:lstStyle/>
+          <a:p>
+            <a:pPr algn="l"/>
+            <a:r>
+              <a:rPr sz="1250" b="0" i="0">
+                <a:solidFill>
+                  <a:srgbClr val="F8FAFC"/>
+                </a:solidFill>
+                <a:latin typeface="Segoe UI"/>
+              </a:rPr>
+              <a:t>Homoglyph детектор</a:t>
+            </a:r>
+          </a:p>
+        </p:txBody>
+      </p:sp>
+      <p:sp>
+        <p:nvSpPr>
+          <p:cNvPr id="33" name="Rectangle 32"/>
+          <p:cNvSpPr/>
+          <p:nvPr/>
+        </p:nvSpPr>
+        <p:spPr>
+          <a:xfrm>
+            <a:off x="8138160" y="1691640"/>
+            <a:ext cx="3776472" cy="4206240"/>
+          </a:xfrm>
+          <a:prstGeom prst="rect">
+            <a:avLst/>
+          </a:prstGeom>
+          <a:solidFill>
+            <a:srgbClr val="0D1426"/>
+          </a:solidFill>
+          <a:ln w="9525">
+            <a:solidFill>
+              <a:srgbClr val="334155"/>
+            </a:solidFill>
+          </a:ln>
+        </p:spPr>
+        <p:style>
+          <a:lnRef idx="1">
+            <a:schemeClr val="accent1"/>
+          </a:lnRef>
+          <a:fillRef idx="3">
+            <a:schemeClr val="accent1"/>
+          </a:fillRef>
+          <a:effectRef idx="2">
+            <a:schemeClr val="accent1"/>
+          </a:effectRef>
+          <a:fontRef idx="minor">
+            <a:schemeClr val="lt1"/>
+          </a:fontRef>
+        </p:style>
+        <p:txBody>
+          <a:bodyPr rtlCol="0" anchor="ctr"/>
+          <a:lstStyle/>
+          <a:p>
+            <a:pPr algn="ctr"/>
+          </a:p>
+        </p:txBody>
+      </p:sp>
+      <p:sp>
+        <p:nvSpPr>
+          <p:cNvPr id="34" name="Rectangle 33"/>
+          <p:cNvSpPr/>
+          <p:nvPr/>
+        </p:nvSpPr>
+        <p:spPr>
+          <a:xfrm>
+            <a:off x="8138160" y="1691640"/>
+            <a:ext cx="3776472" cy="36576"/>
+          </a:xfrm>
+          <a:prstGeom prst="rect">
+            <a:avLst/>
+          </a:prstGeom>
+          <a:solidFill>
+            <a:srgbClr val="3B82F6"/>
+          </a:solidFill>
+          <a:ln>
+            <a:noFill/>
+          </a:ln>
+        </p:spPr>
+        <p:style>
+          <a:lnRef idx="1">
+            <a:schemeClr val="accent1"/>
+          </a:lnRef>
+          <a:fillRef idx="3">
+            <a:schemeClr val="accent1"/>
+          </a:fillRef>
+          <a:effectRef idx="2">
+            <a:schemeClr val="accent1"/>
+          </a:effectRef>
+          <a:fontRef idx="minor">
+            <a:schemeClr val="lt1"/>
+          </a:fontRef>
+        </p:style>
+        <p:txBody>
+          <a:bodyPr rtlCol="0" anchor="ctr"/>
+          <a:lstStyle/>
+          <a:p>
+            <a:pPr algn="ctr"/>
+          </a:p>
+        </p:txBody>
+      </p:sp>
+      <p:sp>
+        <p:nvSpPr>
+          <p:cNvPr id="35" name="TextBox 34"/>
+          <p:cNvSpPr txBox="1"/>
+          <p:nvPr/>
+        </p:nvSpPr>
+        <p:spPr>
+          <a:xfrm>
+            <a:off x="8321040" y="1828800"/>
+            <a:ext cx="3410712" cy="365760"/>
+          </a:xfrm>
+          <a:prstGeom prst="rect">
+            <a:avLst/>
+          </a:prstGeom>
+          <a:noFill/>
+        </p:spPr>
+        <p:txBody>
+          <a:bodyPr wrap="square">
+            <a:spAutoFit/>
+          </a:bodyPr>
+          <a:lstStyle/>
+          <a:p>
+            <a:pPr algn="l"/>
+            <a:r>
+              <a:rPr sz="1500" b="1" i="0">
+                <a:solidFill>
+                  <a:srgbClr val="F8FAFC"/>
+                </a:solidFill>
+                <a:latin typeface="Segoe UI"/>
+              </a:rPr>
+              <a:t>🛡  САПА</a:t>
+            </a:r>
+          </a:p>
+        </p:txBody>
+      </p:sp>
+      <p:sp>
+        <p:nvSpPr>
+          <p:cNvPr id="36" name="Oval 35"/>
+          <p:cNvSpPr/>
+          <p:nvPr/>
+        </p:nvSpPr>
+        <p:spPr>
+          <a:xfrm>
+            <a:off x="8321040" y="2395728"/>
+            <a:ext cx="91440" cy="91440"/>
+          </a:xfrm>
+          <a:prstGeom prst="ellipse">
+            <a:avLst/>
+          </a:prstGeom>
+          <a:solidFill>
+            <a:srgbClr val="3B82F6"/>
+          </a:solidFill>
+          <a:ln>
+            <a:noFill/>
+          </a:ln>
+        </p:spPr>
+        <p:style>
+          <a:lnRef idx="1">
+            <a:schemeClr val="accent1"/>
+          </a:lnRef>
+          <a:fillRef idx="3">
+            <a:schemeClr val="accent1"/>
+          </a:fillRef>
+          <a:effectRef idx="2">
+            <a:schemeClr val="accent1"/>
+          </a:effectRef>
+          <a:fontRef idx="minor">
+            <a:schemeClr val="lt1"/>
+          </a:fontRef>
+        </p:style>
+        <p:txBody>
+          <a:bodyPr rtlCol="0" anchor="ctr"/>
+          <a:lstStyle/>
+          <a:p>
+            <a:pPr algn="ctr"/>
+          </a:p>
+        </p:txBody>
+      </p:sp>
+      <p:sp>
+        <p:nvSpPr>
+          <p:cNvPr id="37" name="TextBox 36"/>
+          <p:cNvSpPr txBox="1"/>
+          <p:nvPr/>
+        </p:nvSpPr>
+        <p:spPr>
+          <a:xfrm>
+            <a:off x="8485632" y="2286000"/>
+            <a:ext cx="3291840" cy="347472"/>
+          </a:xfrm>
+          <a:prstGeom prst="rect">
+            <a:avLst/>
+          </a:prstGeom>
+          <a:noFill/>
+        </p:spPr>
+        <p:txBody>
+          <a:bodyPr wrap="square">
+            <a:spAutoFit/>
+          </a:bodyPr>
+          <a:lstStyle/>
+          <a:p>
+            <a:pPr algn="l"/>
+            <a:r>
+              <a:rPr sz="1250" b="0" i="0">
+                <a:solidFill>
+                  <a:srgbClr val="F8FAFC"/>
+                </a:solidFill>
+                <a:latin typeface="Segoe UI"/>
+              </a:rPr>
+              <a:t>80 автотест + CI</a:t>
+            </a:r>
+          </a:p>
+        </p:txBody>
+      </p:sp>
+      <p:sp>
+        <p:nvSpPr>
+          <p:cNvPr id="38" name="Oval 37"/>
+          <p:cNvSpPr/>
+          <p:nvPr/>
+        </p:nvSpPr>
+        <p:spPr>
+          <a:xfrm>
+            <a:off x="8321040" y="2962656"/>
+            <a:ext cx="91440" cy="91440"/>
+          </a:xfrm>
+          <a:prstGeom prst="ellipse">
+            <a:avLst/>
+          </a:prstGeom>
+          <a:solidFill>
+            <a:srgbClr val="3B82F6"/>
+          </a:solidFill>
+          <a:ln>
+            <a:noFill/>
+          </a:ln>
+        </p:spPr>
+        <p:style>
+          <a:lnRef idx="1">
+            <a:schemeClr val="accent1"/>
+          </a:lnRef>
+          <a:fillRef idx="3">
+            <a:schemeClr val="accent1"/>
+          </a:fillRef>
+          <a:effectRef idx="2">
+            <a:schemeClr val="accent1"/>
+          </a:effectRef>
+          <a:fontRef idx="minor">
+            <a:schemeClr val="lt1"/>
+          </a:fontRef>
+        </p:style>
+        <p:txBody>
+          <a:bodyPr rtlCol="0" anchor="ctr"/>
+          <a:lstStyle/>
+          <a:p>
+            <a:pPr algn="ctr"/>
+          </a:p>
+        </p:txBody>
+      </p:sp>
+      <p:sp>
+        <p:nvSpPr>
+          <p:cNvPr id="39" name="TextBox 38"/>
+          <p:cNvSpPr txBox="1"/>
+          <p:nvPr/>
+        </p:nvSpPr>
+        <p:spPr>
+          <a:xfrm>
+            <a:off x="8485632" y="2852928"/>
+            <a:ext cx="3291840" cy="347472"/>
+          </a:xfrm>
+          <a:prstGeom prst="rect">
+            <a:avLst/>
+          </a:prstGeom>
+          <a:noFill/>
+        </p:spPr>
+        <p:txBody>
+          <a:bodyPr wrap="square">
+            <a:spAutoFit/>
+          </a:bodyPr>
+          <a:lstStyle/>
+          <a:p>
+            <a:pPr algn="l"/>
+            <a:r>
+              <a:rPr sz="1250" b="0" i="0">
+                <a:solidFill>
+                  <a:srgbClr val="F8FAFC"/>
+                </a:solidFill>
+                <a:latin typeface="Segoe UI"/>
+              </a:rPr>
+              <a:t>SSRF / CORS қорғаныс</a:t>
+            </a:r>
+          </a:p>
+        </p:txBody>
+      </p:sp>
+      <p:sp>
+        <p:nvSpPr>
+          <p:cNvPr id="40" name="Oval 39"/>
+          <p:cNvSpPr/>
+          <p:nvPr/>
+        </p:nvSpPr>
+        <p:spPr>
+          <a:xfrm>
+            <a:off x="8321040" y="3529584"/>
+            <a:ext cx="91440" cy="91440"/>
+          </a:xfrm>
+          <a:prstGeom prst="ellipse">
+            <a:avLst/>
+          </a:prstGeom>
+          <a:solidFill>
+            <a:srgbClr val="3B82F6"/>
+          </a:solidFill>
+          <a:ln>
+            <a:noFill/>
+          </a:ln>
+        </p:spPr>
+        <p:style>
+          <a:lnRef idx="1">
+            <a:schemeClr val="accent1"/>
+          </a:lnRef>
+          <a:fillRef idx="3">
+            <a:schemeClr val="accent1"/>
+          </a:fillRef>
+          <a:effectRef idx="2">
+            <a:schemeClr val="accent1"/>
+          </a:effectRef>
+          <a:fontRef idx="minor">
+            <a:schemeClr val="lt1"/>
+          </a:fontRef>
+        </p:style>
+        <p:txBody>
+          <a:bodyPr rtlCol="0" anchor="ctr"/>
+          <a:lstStyle/>
+          <a:p>
+            <a:pPr algn="ctr"/>
+          </a:p>
+        </p:txBody>
+      </p:sp>
+      <p:sp>
+        <p:nvSpPr>
+          <p:cNvPr id="41" name="TextBox 40"/>
+          <p:cNvSpPr txBox="1"/>
+          <p:nvPr/>
+        </p:nvSpPr>
+        <p:spPr>
+          <a:xfrm>
+            <a:off x="8485632" y="3419856"/>
+            <a:ext cx="3291840" cy="347472"/>
+          </a:xfrm>
+          <a:prstGeom prst="rect">
+            <a:avLst/>
+          </a:prstGeom>
+          <a:noFill/>
+        </p:spPr>
+        <p:txBody>
+          <a:bodyPr wrap="square">
+            <a:spAutoFit/>
+          </a:bodyPr>
+          <a:lstStyle/>
+          <a:p>
+            <a:pPr algn="l"/>
+            <a:r>
+              <a:rPr sz="1250" b="0" i="0">
+                <a:solidFill>
+                  <a:srgbClr val="F8FAFC"/>
+                </a:solidFill>
+                <a:latin typeface="Segoe UI"/>
+              </a:rPr>
+              <a:t>6-деңгейлі pipeline (адал)</a:t>
+            </a:r>
+          </a:p>
+        </p:txBody>
+      </p:sp>
+      <p:sp>
+        <p:nvSpPr>
+          <p:cNvPr id="42" name="Oval 41"/>
+          <p:cNvSpPr/>
+          <p:nvPr/>
+        </p:nvSpPr>
+        <p:spPr>
+          <a:xfrm>
+            <a:off x="8321040" y="4096512"/>
+            <a:ext cx="91440" cy="91440"/>
+          </a:xfrm>
+          <a:prstGeom prst="ellipse">
+            <a:avLst/>
+          </a:prstGeom>
+          <a:solidFill>
+            <a:srgbClr val="3B82F6"/>
+          </a:solidFill>
+          <a:ln>
+            <a:noFill/>
+          </a:ln>
+        </p:spPr>
+        <p:style>
+          <a:lnRef idx="1">
+            <a:schemeClr val="accent1"/>
+          </a:lnRef>
+          <a:fillRef idx="3">
+            <a:schemeClr val="accent1"/>
+          </a:fillRef>
+          <a:effectRef idx="2">
+            <a:schemeClr val="accent1"/>
+          </a:effectRef>
+          <a:fontRef idx="minor">
+            <a:schemeClr val="lt1"/>
+          </a:fontRef>
+        </p:style>
+        <p:txBody>
+          <a:bodyPr rtlCol="0" anchor="ctr"/>
+          <a:lstStyle/>
+          <a:p>
+            <a:pPr algn="ctr"/>
+          </a:p>
+        </p:txBody>
+      </p:sp>
+      <p:sp>
+        <p:nvSpPr>
+          <p:cNvPr id="43" name="TextBox 42"/>
+          <p:cNvSpPr txBox="1"/>
+          <p:nvPr/>
+        </p:nvSpPr>
+        <p:spPr>
+          <a:xfrm>
+            <a:off x="8485632" y="3986784"/>
+            <a:ext cx="3291840" cy="347472"/>
+          </a:xfrm>
+          <a:prstGeom prst="rect">
+            <a:avLst/>
+          </a:prstGeom>
+          <a:noFill/>
+        </p:spPr>
+        <p:txBody>
+          <a:bodyPr wrap="square">
+            <a:spAutoFit/>
+          </a:bodyPr>
+          <a:lstStyle/>
+          <a:p>
+            <a:pPr algn="l"/>
+            <a:r>
+              <a:rPr sz="1250" b="0" i="0">
+                <a:solidFill>
+                  <a:srgbClr val="F8FAFC"/>
+                </a:solidFill>
+                <a:latin typeface="Segoe UI"/>
+              </a:rPr>
+              <a:t>Де-монолит (templates/demo)</a:t>
+            </a:r>
+          </a:p>
+        </p:txBody>
+      </p:sp>
+      <p:sp>
+        <p:nvSpPr>
+          <p:cNvPr id="44" name="Oval 43"/>
+          <p:cNvSpPr/>
+          <p:nvPr/>
+        </p:nvSpPr>
+        <p:spPr>
+          <a:xfrm>
+            <a:off x="8321040" y="4663440"/>
+            <a:ext cx="91440" cy="91440"/>
+          </a:xfrm>
+          <a:prstGeom prst="ellipse">
+            <a:avLst/>
+          </a:prstGeom>
+          <a:solidFill>
+            <a:srgbClr val="3B82F6"/>
+          </a:solidFill>
+          <a:ln>
+            <a:noFill/>
+          </a:ln>
+        </p:spPr>
+        <p:style>
+          <a:lnRef idx="1">
+            <a:schemeClr val="accent1"/>
+          </a:lnRef>
+          <a:fillRef idx="3">
+            <a:schemeClr val="accent1"/>
+          </a:fillRef>
+          <a:effectRef idx="2">
+            <a:schemeClr val="accent1"/>
+          </a:effectRef>
+          <a:fontRef idx="minor">
+            <a:schemeClr val="lt1"/>
+          </a:fontRef>
+        </p:style>
+        <p:txBody>
+          <a:bodyPr rtlCol="0" anchor="ctr"/>
+          <a:lstStyle/>
+          <a:p>
+            <a:pPr algn="ctr"/>
+          </a:p>
+        </p:txBody>
+      </p:sp>
+      <p:sp>
+        <p:nvSpPr>
+          <p:cNvPr id="45" name="TextBox 44"/>
+          <p:cNvSpPr txBox="1"/>
+          <p:nvPr/>
+        </p:nvSpPr>
+        <p:spPr>
+          <a:xfrm>
+            <a:off x="8485632" y="4553712"/>
+            <a:ext cx="3291840" cy="347472"/>
+          </a:xfrm>
+          <a:prstGeom prst="rect">
+            <a:avLst/>
+          </a:prstGeom>
+          <a:noFill/>
+        </p:spPr>
+        <p:txBody>
+          <a:bodyPr wrap="square">
+            <a:spAutoFit/>
+          </a:bodyPr>
+          <a:lstStyle/>
+          <a:p>
+            <a:pPr algn="l"/>
+            <a:r>
+              <a:rPr sz="1250" b="0" i="0">
+                <a:solidFill>
+                  <a:srgbClr val="F8FAFC"/>
+                </a:solidFill>
+                <a:latin typeface="Segoe UI"/>
+              </a:rPr>
+              <a:t>Бәрі продакшенде</a:t>
+            </a:r>
+          </a:p>
+        </p:txBody>
+      </p:sp>
+      <p:sp>
+        <p:nvSpPr>
+          <p:cNvPr id="46" name="Rectangle 45"/>
+          <p:cNvSpPr/>
+          <p:nvPr/>
+        </p:nvSpPr>
+        <p:spPr>
+          <a:xfrm>
+            <a:off x="274320" y="6172200"/>
+            <a:ext cx="11640312" cy="384048"/>
+          </a:xfrm>
+          <a:prstGeom prst="rect">
+            <a:avLst/>
+          </a:prstGeom>
+          <a:solidFill>
+            <a:srgbClr val="050D1E"/>
+          </a:solidFill>
+          <a:ln>
+            <a:noFill/>
+          </a:ln>
+        </p:spPr>
+        <p:style>
+          <a:lnRef idx="1">
+            <a:schemeClr val="accent1"/>
+          </a:lnRef>
+          <a:fillRef idx="3">
+            <a:schemeClr val="accent1"/>
+          </a:fillRef>
+          <a:effectRef idx="2">
+            <a:schemeClr val="accent1"/>
+          </a:effectRef>
+          <a:fontRef idx="minor">
+            <a:schemeClr val="lt1"/>
+          </a:fontRef>
+        </p:style>
+        <p:txBody>
+          <a:bodyPr rtlCol="0" anchor="ctr"/>
+          <a:lstStyle/>
+          <a:p>
+            <a:pPr algn="ctr"/>
+          </a:p>
+        </p:txBody>
+      </p:sp>
+      <p:sp>
+        <p:nvSpPr>
+          <p:cNvPr id="47" name="TextBox 46"/>
+          <p:cNvSpPr txBox="1"/>
+          <p:nvPr/>
+        </p:nvSpPr>
+        <p:spPr>
+          <a:xfrm>
+            <a:off x="274320" y="6190488"/>
+            <a:ext cx="11640312" cy="365760"/>
+          </a:xfrm>
+          <a:prstGeom prst="rect">
+            <a:avLst/>
+          </a:prstGeom>
+          <a:noFill/>
+        </p:spPr>
+        <p:txBody>
+          <a:bodyPr wrap="square">
+            <a:spAutoFit/>
+          </a:bodyPr>
+          <a:lstStyle/>
+          <a:p>
+            <a:pPr algn="ctr"/>
+            <a:r>
+              <a:rPr sz="1300" b="1" i="0">
+                <a:solidFill>
+                  <a:srgbClr val="60A5FA"/>
+                </a:solidFill>
+                <a:latin typeface="Segoe UI"/>
+              </a:rPr>
+              <a:t>🌐  Барлығы live: qalqan-ai-nu.vercel.app  ·  @QalqanAI_bot  ·  80 тест жасыл</a:t>
             </a:r>
           </a:p>
         </p:txBody>

</xml_diff>